<commit_message>
Keep single dark navy slide in executive PPT profile, remove white slide
</commit_message>
<xml_diff>
--- a/Dr_G_Hari_Prakash_Executive_Profile.pptx
+++ b/Dr_G_Hari_Prakash_Executive_Profile.pptx
@@ -6,7 +6,6 @@
   </p:sldMasterIdLst>
   <p:sldIdLst>
     <p:sldId id="256" r:id="rId7"/>
-    <p:sldId id="257" r:id="rId8"/>
   </p:sldIdLst>
   <p:sldSz cx="12191695" cy="6858000" type="screen4x3"/>
   <p:notesSz cx="6858000" cy="9144000"/>
@@ -4213,1156 +4212,6 @@
               <a:rPr sz="919">
                 <a:solidFill>
                   <a:srgbClr val="B9CDE6"/>
-                </a:solidFill>
-                <a:latin typeface="Calibri"/>
-              </a:rPr>
-              <a:t>European Society of Medical Oncology (ESMO)   |   ESMO &amp; JSMO Travel Fellowship Awardee</a:t>
-            </a:r>
-          </a:p>
-        </p:txBody>
-      </p:sp>
-    </p:spTree>
-  </p:cSld>
-  <p:clrMapOvr>
-    <a:masterClrMapping/>
-  </p:clrMapOvr>
-</p:sld>
-</file>
-
-<file path=ppt/slides/slide2.xml><?xml version="1.0" encoding="utf-8"?>
-<p:sld xmlns:a="http://schemas.openxmlformats.org/drawingml/2006/main" xmlns:p="http://schemas.openxmlformats.org/presentationml/2006/main" xmlns:r="http://schemas.openxmlformats.org/officeDocument/2006/relationships">
-  <p:cSld>
-    <p:spTree>
-      <p:nvGrpSpPr>
-        <p:cNvPr id="1" name=""/>
-        <p:cNvGrpSpPr/>
-        <p:nvPr/>
-      </p:nvGrpSpPr>
-      <p:grpSpPr/>
-      <p:sp>
-        <p:nvSpPr>
-          <p:cNvPr id="2" name="Rectangle 1"/>
-          <p:cNvSpPr/>
-          <p:nvPr/>
-        </p:nvSpPr>
-        <p:spPr>
-          <a:xfrm>
-            <a:off x="0" y="0"/>
-            <a:ext cx="12191695" cy="6858000"/>
-          </a:xfrm>
-          <a:prstGeom prst="rect">
-            <a:avLst/>
-          </a:prstGeom>
-          <a:solidFill>
-            <a:srgbClr val="F6F8FC"/>
-          </a:solidFill>
-          <a:ln>
-            <a:noFill/>
-          </a:ln>
-        </p:spPr>
-        <p:style>
-          <a:lnRef idx="1">
-            <a:schemeClr val="accent1"/>
-          </a:lnRef>
-          <a:fillRef idx="3">
-            <a:schemeClr val="accent1"/>
-          </a:fillRef>
-          <a:effectRef idx="2">
-            <a:schemeClr val="accent1"/>
-          </a:effectRef>
-          <a:fontRef idx="minor">
-            <a:schemeClr val="lt1"/>
-          </a:fontRef>
-        </p:style>
-        <p:txBody>
-          <a:bodyPr rtlCol="0" anchor="ctr"/>
-          <a:lstStyle/>
-          <a:p>
-            <a:pPr algn="ctr"/>
-          </a:p>
-        </p:txBody>
-      </p:sp>
-      <p:sp>
-        <p:nvSpPr>
-          <p:cNvPr id="3" name="Rounded Rectangle 2"/>
-          <p:cNvSpPr/>
-          <p:nvPr/>
-        </p:nvSpPr>
-        <p:spPr>
-          <a:xfrm>
-            <a:off x="548640" y="548640"/>
-            <a:ext cx="3291840" cy="5760720"/>
-          </a:xfrm>
-          <a:prstGeom prst="roundRect">
-            <a:avLst/>
-          </a:prstGeom>
-          <a:solidFill>
-            <a:srgbClr val="0F2340"/>
-          </a:solidFill>
-          <a:ln w="19050">
-            <a:solidFill>
-              <a:srgbClr val="1A6B6B"/>
-            </a:solidFill>
-          </a:ln>
-        </p:spPr>
-        <p:style>
-          <a:lnRef idx="1">
-            <a:schemeClr val="accent1"/>
-          </a:lnRef>
-          <a:fillRef idx="3">
-            <a:schemeClr val="accent1"/>
-          </a:fillRef>
-          <a:effectRef idx="2">
-            <a:schemeClr val="accent1"/>
-          </a:effectRef>
-          <a:fontRef idx="minor">
-            <a:schemeClr val="lt1"/>
-          </a:fontRef>
-        </p:style>
-        <p:txBody>
-          <a:bodyPr rtlCol="0" anchor="ctr"/>
-          <a:lstStyle/>
-          <a:p>
-            <a:pPr algn="ctr"/>
-          </a:p>
-        </p:txBody>
-      </p:sp>
-      <p:pic>
-        <p:nvPicPr>
-          <p:cNvPr id="4" name="Picture 3" descr="hari-prakash-circle.png"/>
-          <p:cNvPicPr>
-            <a:picLocks noChangeAspect="1"/>
-          </p:cNvPicPr>
-          <p:nvPr/>
-        </p:nvPicPr>
-        <p:blipFill>
-          <a:blip r:embed="rId2"/>
-          <a:stretch>
-            <a:fillRect/>
-          </a:stretch>
-        </p:blipFill>
-        <p:spPr>
-          <a:xfrm>
-            <a:off x="1188720" y="822960"/>
-            <a:ext cx="2011680" cy="2011680"/>
-          </a:xfrm>
-          <a:prstGeom prst="rect">
-            <a:avLst/>
-          </a:prstGeom>
-        </p:spPr>
-      </p:pic>
-      <p:sp>
-        <p:nvSpPr>
-          <p:cNvPr id="5" name="TextBox 4"/>
-          <p:cNvSpPr txBox="1"/>
-          <p:nvPr/>
-        </p:nvSpPr>
-        <p:spPr>
-          <a:xfrm>
-            <a:off x="685800" y="2926080"/>
-            <a:ext cx="3017520" cy="3200400"/>
-          </a:xfrm>
-          <a:prstGeom prst="rect">
-            <a:avLst/>
-          </a:prstGeom>
-          <a:noFill/>
-        </p:spPr>
-        <p:txBody>
-          <a:bodyPr wrap="square" lIns="0" rIns="0" tIns="0" bIns="0">
-            <a:spAutoFit/>
-          </a:bodyPr>
-          <a:lstStyle/>
-          <a:p>
-            <a:pPr algn="ctr"/>
-            <a:r>
-              <a:rPr sz="1900" b="1">
-                <a:solidFill>
-                  <a:srgbClr val="FFFFFF"/>
-                </a:solidFill>
-                <a:latin typeface="Georgia"/>
-              </a:rPr>
-              <a:t>Dr G. Hari Prakash</a:t>
-            </a:r>
-          </a:p>
-          <a:p>
-            <a:pPr algn="ctr">
-              <a:spcBef>
-                <a:spcPts val="500"/>
-              </a:spcBef>
-            </a:pPr>
-            <a:r>
-              <a:rPr sz="1200" b="1">
-                <a:solidFill>
-                  <a:srgbClr val="50D2D2"/>
-                </a:solidFill>
-                <a:latin typeface="Calibri"/>
-              </a:rPr>
-              <a:t>Assistant Professor (Public Health)</a:t>
-            </a:r>
-          </a:p>
-          <a:p>
-            <a:pPr algn="ctr">
-              <a:spcBef>
-                <a:spcPts val="300"/>
-              </a:spcBef>
-            </a:pPr>
-            <a:r>
-              <a:rPr sz="1000">
-                <a:solidFill>
-                  <a:srgbClr val="DCE6F5"/>
-                </a:solidFill>
-                <a:latin typeface="Calibri"/>
-              </a:rPr>
-              <a:t>Ramaiah School of Public Health
-MS Ramaiah Univ. of Applied Sciences, India</a:t>
-            </a:r>
-          </a:p>
-          <a:p>
-            <a:pPr algn="ctr">
-              <a:spcBef>
-                <a:spcPts val="600"/>
-              </a:spcBef>
-            </a:pPr>
-            <a:r>
-              <a:rPr sz="1050" b="1">
-                <a:solidFill>
-                  <a:srgbClr val="EBAF6E"/>
-                </a:solidFill>
-                <a:latin typeface="Calibri"/>
-              </a:rPr>
-              <a:t>PhD (Public Health) · Pharm.D · MPH</a:t>
-            </a:r>
-          </a:p>
-        </p:txBody>
-      </p:sp>
-      <p:sp>
-        <p:nvSpPr>
-          <p:cNvPr id="6" name="Rectangle 5"/>
-          <p:cNvSpPr/>
-          <p:nvPr/>
-        </p:nvSpPr>
-        <p:spPr>
-          <a:xfrm>
-            <a:off x="914400" y="4617720"/>
-            <a:ext cx="2560320" cy="12700"/>
-          </a:xfrm>
-          <a:prstGeom prst="rect">
-            <a:avLst/>
-          </a:prstGeom>
-          <a:solidFill>
-            <a:srgbClr val="284B78"/>
-          </a:solidFill>
-          <a:ln>
-            <a:noFill/>
-          </a:ln>
-        </p:spPr>
-        <p:style>
-          <a:lnRef idx="1">
-            <a:schemeClr val="accent1"/>
-          </a:lnRef>
-          <a:fillRef idx="3">
-            <a:schemeClr val="accent1"/>
-          </a:fillRef>
-          <a:effectRef idx="2">
-            <a:schemeClr val="accent1"/>
-          </a:effectRef>
-          <a:fontRef idx="minor">
-            <a:schemeClr val="lt1"/>
-          </a:fontRef>
-        </p:style>
-        <p:txBody>
-          <a:bodyPr rtlCol="0" anchor="ctr"/>
-          <a:lstStyle/>
-          <a:p>
-            <a:pPr algn="ctr"/>
-          </a:p>
-        </p:txBody>
-      </p:sp>
-      <p:sp>
-        <p:nvSpPr>
-          <p:cNvPr id="7" name="TextBox 6"/>
-          <p:cNvSpPr txBox="1"/>
-          <p:nvPr/>
-        </p:nvSpPr>
-        <p:spPr>
-          <a:xfrm>
-            <a:off x="731520" y="4709160"/>
-            <a:ext cx="2926080" cy="1463040"/>
-          </a:xfrm>
-          <a:prstGeom prst="rect">
-            <a:avLst/>
-          </a:prstGeom>
-          <a:noFill/>
-        </p:spPr>
-        <p:txBody>
-          <a:bodyPr wrap="square" lIns="0" rIns="0" tIns="0" bIns="0">
-            <a:spAutoFit/>
-          </a:bodyPr>
-          <a:lstStyle/>
-          <a:p>
-            <a:pPr>
-              <a:spcBef>
-                <a:spcPts val="300"/>
-              </a:spcBef>
-            </a:pPr>
-            <a:r>
-              <a:rPr sz="950">
-                <a:solidFill>
-                  <a:srgbClr val="AABED7"/>
-                </a:solidFill>
-                <a:latin typeface="Calibri"/>
-              </a:rPr>
-              <a:t>🌐  Website: </a:t>
-            </a:r>
-            <a:r>
-              <a:rPr sz="950" b="1">
-                <a:solidFill>
-                  <a:srgbClr val="F5FAFF"/>
-                </a:solidFill>
-                <a:latin typeface="Calibri"/>
-              </a:rPr>
-              <a:t>www.drhari.co.in</a:t>
-            </a:r>
-          </a:p>
-          <a:p>
-            <a:pPr>
-              <a:spcBef>
-                <a:spcPts val="300"/>
-              </a:spcBef>
-            </a:pPr>
-            <a:r>
-              <a:rPr sz="950">
-                <a:solidFill>
-                  <a:srgbClr val="AABED7"/>
-                </a:solidFill>
-                <a:latin typeface="Calibri"/>
-              </a:rPr>
-              <a:t>✉  Email: </a:t>
-            </a:r>
-            <a:r>
-              <a:rPr sz="950" b="1">
-                <a:solidFill>
-                  <a:srgbClr val="F5FAFF"/>
-                </a:solidFill>
-                <a:latin typeface="Calibri"/>
-              </a:rPr>
-              <a:t>hariprakash607@gmail.com</a:t>
-            </a:r>
-          </a:p>
-          <a:p>
-            <a:pPr>
-              <a:spcBef>
-                <a:spcPts val="300"/>
-              </a:spcBef>
-            </a:pPr>
-            <a:r>
-              <a:rPr sz="950">
-                <a:solidFill>
-                  <a:srgbClr val="AABED7"/>
-                </a:solidFill>
-                <a:latin typeface="Calibri"/>
-              </a:rPr>
-              <a:t>📱  Phone: </a:t>
-            </a:r>
-            <a:r>
-              <a:rPr sz="950" b="1">
-                <a:solidFill>
-                  <a:srgbClr val="F5FAFF"/>
-                </a:solidFill>
-                <a:latin typeface="Calibri"/>
-              </a:rPr>
-              <a:t>+91 7306789341</a:t>
-            </a:r>
-          </a:p>
-          <a:p>
-            <a:pPr>
-              <a:spcBef>
-                <a:spcPts val="300"/>
-              </a:spcBef>
-            </a:pPr>
-            <a:r>
-              <a:rPr sz="950">
-                <a:solidFill>
-                  <a:srgbClr val="AABED7"/>
-                </a:solidFill>
-                <a:latin typeface="Calibri"/>
-              </a:rPr>
-              <a:t>🆔  ORCID: </a:t>
-            </a:r>
-            <a:r>
-              <a:rPr sz="950" b="1">
-                <a:solidFill>
-                  <a:srgbClr val="F5FAFF"/>
-                </a:solidFill>
-                <a:latin typeface="Calibri"/>
-              </a:rPr>
-              <a:t>0000-0002-9463-4084</a:t>
-            </a:r>
-          </a:p>
-        </p:txBody>
-      </p:sp>
-      <p:sp>
-        <p:nvSpPr>
-          <p:cNvPr id="8" name="Rounded Rectangle 7"/>
-          <p:cNvSpPr/>
-          <p:nvPr/>
-        </p:nvSpPr>
-        <p:spPr>
-          <a:xfrm>
-            <a:off x="4114800" y="548640"/>
-            <a:ext cx="1801368" cy="1097280"/>
-          </a:xfrm>
-          <a:prstGeom prst="roundRect">
-            <a:avLst/>
-          </a:prstGeom>
-          <a:solidFill>
-            <a:srgbClr val="FFFFFF"/>
-          </a:solidFill>
-          <a:ln w="15240">
-            <a:solidFill>
-              <a:srgbClr val="D7E1EE"/>
-            </a:solidFill>
-          </a:ln>
-        </p:spPr>
-        <p:style>
-          <a:lnRef idx="1">
-            <a:schemeClr val="accent1"/>
-          </a:lnRef>
-          <a:fillRef idx="3">
-            <a:schemeClr val="accent1"/>
-          </a:fillRef>
-          <a:effectRef idx="2">
-            <a:schemeClr val="accent1"/>
-          </a:effectRef>
-          <a:fontRef idx="minor">
-            <a:schemeClr val="lt1"/>
-          </a:fontRef>
-        </p:style>
-        <p:txBody>
-          <a:bodyPr rtlCol="0" anchor="ctr" wrap="square" tIns="50800" bIns="50800" lIns="50800" rIns="50800"/>
-          <a:lstStyle/>
-          <a:p>
-            <a:pPr algn="ctr"/>
-            <a:r>
-              <a:rPr sz="1800" b="1">
-                <a:solidFill>
-                  <a:srgbClr val="C47C3E"/>
-                </a:solidFill>
-                <a:latin typeface="Georgia"/>
-              </a:rPr>
-              <a:t>45+</a:t>
-            </a:r>
-          </a:p>
-          <a:p>
-            <a:pPr algn="ctr">
-              <a:spcBef>
-                <a:spcPts val="200"/>
-              </a:spcBef>
-            </a:pPr>
-            <a:r>
-              <a:rPr sz="950" b="1">
-                <a:solidFill>
-                  <a:srgbClr val="0F2340"/>
-                </a:solidFill>
-                <a:latin typeface="Calibri"/>
-              </a:rPr>
-              <a:t>Publications</a:t>
-            </a:r>
-          </a:p>
-          <a:p>
-            <a:pPr algn="ctr">
-              <a:spcBef>
-                <a:spcPts val="100"/>
-              </a:spcBef>
-            </a:pPr>
-            <a:r>
-              <a:rPr sz="750">
-                <a:solidFill>
-                  <a:srgbClr val="647387"/>
-                </a:solidFill>
-                <a:latin typeface="Calibri"/>
-              </a:rPr>
-              <a:t>Peer-reviewed papers (IF up to 56.7)</a:t>
-            </a:r>
-          </a:p>
-        </p:txBody>
-      </p:sp>
-      <p:sp>
-        <p:nvSpPr>
-          <p:cNvPr id="9" name="Rounded Rectangle 8"/>
-          <p:cNvSpPr/>
-          <p:nvPr/>
-        </p:nvSpPr>
-        <p:spPr>
-          <a:xfrm>
-            <a:off x="6080760" y="548640"/>
-            <a:ext cx="1801368" cy="1097280"/>
-          </a:xfrm>
-          <a:prstGeom prst="roundRect">
-            <a:avLst/>
-          </a:prstGeom>
-          <a:solidFill>
-            <a:srgbClr val="FFFFFF"/>
-          </a:solidFill>
-          <a:ln w="15240">
-            <a:solidFill>
-              <a:srgbClr val="D7E1EE"/>
-            </a:solidFill>
-          </a:ln>
-        </p:spPr>
-        <p:style>
-          <a:lnRef idx="1">
-            <a:schemeClr val="accent1"/>
-          </a:lnRef>
-          <a:fillRef idx="3">
-            <a:schemeClr val="accent1"/>
-          </a:fillRef>
-          <a:effectRef idx="2">
-            <a:schemeClr val="accent1"/>
-          </a:effectRef>
-          <a:fontRef idx="minor">
-            <a:schemeClr val="lt1"/>
-          </a:fontRef>
-        </p:style>
-        <p:txBody>
-          <a:bodyPr rtlCol="0" anchor="ctr" wrap="square" tIns="50800" bIns="50800" lIns="50800" rIns="50800"/>
-          <a:lstStyle/>
-          <a:p>
-            <a:pPr algn="ctr"/>
-            <a:r>
-              <a:rPr sz="1800" b="1">
-                <a:solidFill>
-                  <a:srgbClr val="C47C3E"/>
-                </a:solidFill>
-                <a:latin typeface="Georgia"/>
-              </a:rPr>
-              <a:t>10+</a:t>
-            </a:r>
-          </a:p>
-          <a:p>
-            <a:pPr algn="ctr">
-              <a:spcBef>
-                <a:spcPts val="200"/>
-              </a:spcBef>
-            </a:pPr>
-            <a:r>
-              <a:rPr sz="950" b="1">
-                <a:solidFill>
-                  <a:srgbClr val="0F2340"/>
-                </a:solidFill>
-                <a:latin typeface="Calibri"/>
-              </a:rPr>
-              <a:t>Digital Health Tools</a:t>
-            </a:r>
-          </a:p>
-          <a:p>
-            <a:pPr algn="ctr">
-              <a:spcBef>
-                <a:spcPts val="100"/>
-              </a:spcBef>
-            </a:pPr>
-            <a:r>
-              <a:rPr sz="750">
-                <a:solidFill>
-                  <a:srgbClr val="647387"/>
-                </a:solidFill>
-                <a:latin typeface="Calibri"/>
-              </a:rPr>
-              <a:t>Deployed platforms (Onco Care, Vichara)</a:t>
-            </a:r>
-          </a:p>
-        </p:txBody>
-      </p:sp>
-      <p:sp>
-        <p:nvSpPr>
-          <p:cNvPr id="10" name="Rounded Rectangle 9"/>
-          <p:cNvSpPr/>
-          <p:nvPr/>
-        </p:nvSpPr>
-        <p:spPr>
-          <a:xfrm>
-            <a:off x="8046720" y="548640"/>
-            <a:ext cx="1801368" cy="1097280"/>
-          </a:xfrm>
-          <a:prstGeom prst="roundRect">
-            <a:avLst/>
-          </a:prstGeom>
-          <a:solidFill>
-            <a:srgbClr val="FFFFFF"/>
-          </a:solidFill>
-          <a:ln w="15240">
-            <a:solidFill>
-              <a:srgbClr val="D7E1EE"/>
-            </a:solidFill>
-          </a:ln>
-        </p:spPr>
-        <p:style>
-          <a:lnRef idx="1">
-            <a:schemeClr val="accent1"/>
-          </a:lnRef>
-          <a:fillRef idx="3">
-            <a:schemeClr val="accent1"/>
-          </a:fillRef>
-          <a:effectRef idx="2">
-            <a:schemeClr val="accent1"/>
-          </a:effectRef>
-          <a:fontRef idx="minor">
-            <a:schemeClr val="lt1"/>
-          </a:fontRef>
-        </p:style>
-        <p:txBody>
-          <a:bodyPr rtlCol="0" anchor="ctr" wrap="square" tIns="50800" bIns="50800" lIns="50800" rIns="50800"/>
-          <a:lstStyle/>
-          <a:p>
-            <a:pPr algn="ctr"/>
-            <a:r>
-              <a:rPr sz="1800" b="1">
-                <a:solidFill>
-                  <a:srgbClr val="C47C3E"/>
-                </a:solidFill>
-                <a:latin typeface="Georgia"/>
-              </a:rPr>
-              <a:t>1</a:t>
-            </a:r>
-          </a:p>
-          <a:p>
-            <a:pPr algn="ctr">
-              <a:spcBef>
-                <a:spcPts val="200"/>
-              </a:spcBef>
-            </a:pPr>
-            <a:r>
-              <a:rPr sz="950" b="1">
-                <a:solidFill>
-                  <a:srgbClr val="0F2340"/>
-                </a:solidFill>
-                <a:latin typeface="Calibri"/>
-              </a:rPr>
-              <a:t>Patent Published</a:t>
-            </a:r>
-          </a:p>
-          <a:p>
-            <a:pPr algn="ctr">
-              <a:spcBef>
-                <a:spcPts val="100"/>
-              </a:spcBef>
-            </a:pPr>
-            <a:r>
-              <a:rPr sz="750">
-                <a:solidFill>
-                  <a:srgbClr val="647387"/>
-                </a:solidFill>
-                <a:latin typeface="Calibri"/>
-              </a:rPr>
-              <a:t>Medical Technology device patent</a:t>
-            </a:r>
-          </a:p>
-        </p:txBody>
-      </p:sp>
-      <p:sp>
-        <p:nvSpPr>
-          <p:cNvPr id="11" name="Rounded Rectangle 10"/>
-          <p:cNvSpPr/>
-          <p:nvPr/>
-        </p:nvSpPr>
-        <p:spPr>
-          <a:xfrm>
-            <a:off x="10012680" y="548640"/>
-            <a:ext cx="1801368" cy="1097280"/>
-          </a:xfrm>
-          <a:prstGeom prst="roundRect">
-            <a:avLst/>
-          </a:prstGeom>
-          <a:solidFill>
-            <a:srgbClr val="FFFFFF"/>
-          </a:solidFill>
-          <a:ln w="15240">
-            <a:solidFill>
-              <a:srgbClr val="D7E1EE"/>
-            </a:solidFill>
-          </a:ln>
-        </p:spPr>
-        <p:style>
-          <a:lnRef idx="1">
-            <a:schemeClr val="accent1"/>
-          </a:lnRef>
-          <a:fillRef idx="3">
-            <a:schemeClr val="accent1"/>
-          </a:fillRef>
-          <a:effectRef idx="2">
-            <a:schemeClr val="accent1"/>
-          </a:effectRef>
-          <a:fontRef idx="minor">
-            <a:schemeClr val="lt1"/>
-          </a:fontRef>
-        </p:style>
-        <p:txBody>
-          <a:bodyPr rtlCol="0" anchor="ctr" wrap="square" tIns="50800" bIns="50800" lIns="50800" rIns="50800"/>
-          <a:lstStyle/>
-          <a:p>
-            <a:pPr algn="ctr"/>
-            <a:r>
-              <a:rPr sz="1600" b="1">
-                <a:solidFill>
-                  <a:srgbClr val="C47C3E"/>
-                </a:solidFill>
-                <a:latin typeface="Georgia"/>
-              </a:rPr>
-              <a:t>ESMO / JSMO</a:t>
-            </a:r>
-          </a:p>
-          <a:p>
-            <a:pPr algn="ctr">
-              <a:spcBef>
-                <a:spcPts val="200"/>
-              </a:spcBef>
-            </a:pPr>
-            <a:r>
-              <a:rPr sz="950" b="1">
-                <a:solidFill>
-                  <a:srgbClr val="0F2340"/>
-                </a:solidFill>
-                <a:latin typeface="Calibri"/>
-              </a:rPr>
-              <a:t>International Awards</a:t>
-            </a:r>
-          </a:p>
-          <a:p>
-            <a:pPr algn="ctr">
-              <a:spcBef>
-                <a:spcPts val="100"/>
-              </a:spcBef>
-            </a:pPr>
-            <a:r>
-              <a:rPr sz="750">
-                <a:solidFill>
-                  <a:srgbClr val="647387"/>
-                </a:solidFill>
-                <a:latin typeface="Calibri"/>
-              </a:rPr>
-              <a:t>Travel Grants (Europe &amp; Japan)</a:t>
-            </a:r>
-          </a:p>
-        </p:txBody>
-      </p:sp>
-      <p:sp>
-        <p:nvSpPr>
-          <p:cNvPr id="12" name="Rounded Rectangle 11"/>
-          <p:cNvSpPr/>
-          <p:nvPr/>
-        </p:nvSpPr>
-        <p:spPr>
-          <a:xfrm>
-            <a:off x="4114800" y="1828800"/>
-            <a:ext cx="3721608" cy="2926080"/>
-          </a:xfrm>
-          <a:prstGeom prst="roundRect">
-            <a:avLst/>
-          </a:prstGeom>
-          <a:solidFill>
-            <a:srgbClr val="FFFFFF"/>
-          </a:solidFill>
-          <a:ln w="15240">
-            <a:solidFill>
-              <a:srgbClr val="D7E1EE"/>
-            </a:solidFill>
-          </a:ln>
-        </p:spPr>
-        <p:style>
-          <a:lnRef idx="1">
-            <a:schemeClr val="accent1"/>
-          </a:lnRef>
-          <a:fillRef idx="3">
-            <a:schemeClr val="accent1"/>
-          </a:fillRef>
-          <a:effectRef idx="2">
-            <a:schemeClr val="accent1"/>
-          </a:effectRef>
-          <a:fontRef idx="minor">
-            <a:schemeClr val="lt1"/>
-          </a:fontRef>
-        </p:style>
-        <p:txBody>
-          <a:bodyPr rtlCol="0" anchor="ctr" wrap="square" tIns="164592" lIns="201168" rIns="201168" bIns="164592"/>
-          <a:lstStyle/>
-          <a:p>
-            <a:pPr algn="ctr"/>
-            <a:r>
-              <a:rPr sz="1100" b="1">
-                <a:solidFill>
-                  <a:srgbClr val="1A6B6B"/>
-                </a:solidFill>
-                <a:latin typeface="Calibri"/>
-              </a:rPr>
-              <a:t>RESEARCH &amp; INNOVATION FOCUS</a:t>
-            </a:r>
-          </a:p>
-          <a:p>
-            <a:pPr>
-              <a:spcBef>
-                <a:spcPts val="600"/>
-              </a:spcBef>
-            </a:pPr>
-            <a:r>
-              <a:rPr sz="950" b="1">
-                <a:solidFill>
-                  <a:srgbClr val="0F2340"/>
-                </a:solidFill>
-                <a:latin typeface="Calibri"/>
-              </a:rPr>
-              <a:t>▪  Digital Health &amp; mHealth Interventions: </a:t>
-            </a:r>
-            <a:r>
-              <a:rPr sz="900">
-                <a:solidFill>
-                  <a:srgbClr val="555F73"/>
-                </a:solidFill>
-                <a:latin typeface="Calibri"/>
-              </a:rPr>
-              <a:t>User-centred co-design, psychometric scales, symptom tracking &amp; patient adherence platforms.</a:t>
-            </a:r>
-          </a:p>
-          <a:p>
-            <a:pPr>
-              <a:spcBef>
-                <a:spcPts val="600"/>
-              </a:spcBef>
-            </a:pPr>
-            <a:r>
-              <a:rPr sz="950" b="1">
-                <a:solidFill>
-                  <a:srgbClr val="0F2340"/>
-                </a:solidFill>
-                <a:latin typeface="Calibri"/>
-              </a:rPr>
-              <a:t>▪  Oncology Care Delivery: </a:t>
-            </a:r>
-            <a:r>
-              <a:rPr sz="900">
-                <a:solidFill>
-                  <a:srgbClr val="555F73"/>
-                </a:solidFill>
-                <a:latin typeface="Calibri"/>
-              </a:rPr>
-              <a:t>Scalable mHealth interventions to reduce cancer care disparities in low- &amp; middle-income settings.</a:t>
-            </a:r>
-          </a:p>
-          <a:p>
-            <a:pPr>
-              <a:spcBef>
-                <a:spcPts val="600"/>
-              </a:spcBef>
-            </a:pPr>
-            <a:r>
-              <a:rPr sz="950" b="1">
-                <a:solidFill>
-                  <a:srgbClr val="0F2340"/>
-                </a:solidFill>
-                <a:latin typeface="Calibri"/>
-              </a:rPr>
-              <a:t>▪  Health Technology Assessment (HTA): </a:t>
-            </a:r>
-            <a:r>
-              <a:rPr sz="900">
-                <a:solidFill>
-                  <a:srgbClr val="555F73"/>
-                </a:solidFill>
-                <a:latin typeface="Calibri"/>
-              </a:rPr>
-              <a:t>Cost-effectiveness, health economic modelling, and technology appraisal.</a:t>
-            </a:r>
-          </a:p>
-          <a:p>
-            <a:pPr>
-              <a:spcBef>
-                <a:spcPts val="600"/>
-              </a:spcBef>
-            </a:pPr>
-            <a:r>
-              <a:rPr sz="950" b="1">
-                <a:solidFill>
-                  <a:srgbClr val="0F2340"/>
-                </a:solidFill>
-                <a:latin typeface="Calibri"/>
-              </a:rPr>
-              <a:t>▪  Implementation Science &amp; AI for Health: </a:t>
-            </a:r>
-            <a:r>
-              <a:rPr sz="900">
-                <a:solidFill>
-                  <a:srgbClr val="555F73"/>
-                </a:solidFill>
-                <a:latin typeface="Calibri"/>
-              </a:rPr>
-              <a:t>Machine-learning decision support, quasi-experimental &amp; target trial emulation methods.</a:t>
-            </a:r>
-          </a:p>
-        </p:txBody>
-      </p:sp>
-      <p:sp>
-        <p:nvSpPr>
-          <p:cNvPr id="13" name="Rounded Rectangle 12"/>
-          <p:cNvSpPr/>
-          <p:nvPr/>
-        </p:nvSpPr>
-        <p:spPr>
-          <a:xfrm>
-            <a:off x="8092440" y="1828800"/>
-            <a:ext cx="3721608" cy="2926080"/>
-          </a:xfrm>
-          <a:prstGeom prst="roundRect">
-            <a:avLst/>
-          </a:prstGeom>
-          <a:solidFill>
-            <a:srgbClr val="FFFFFF"/>
-          </a:solidFill>
-          <a:ln w="15240">
-            <a:solidFill>
-              <a:srgbClr val="D7E1EE"/>
-            </a:solidFill>
-          </a:ln>
-        </p:spPr>
-        <p:style>
-          <a:lnRef idx="1">
-            <a:schemeClr val="accent1"/>
-          </a:lnRef>
-          <a:fillRef idx="3">
-            <a:schemeClr val="accent1"/>
-          </a:fillRef>
-          <a:effectRef idx="2">
-            <a:schemeClr val="accent1"/>
-          </a:effectRef>
-          <a:fontRef idx="minor">
-            <a:schemeClr val="lt1"/>
-          </a:fontRef>
-        </p:style>
-        <p:txBody>
-          <a:bodyPr rtlCol="0" anchor="ctr" wrap="square" tIns="164592" lIns="201168" rIns="201168" bIns="164592"/>
-          <a:lstStyle/>
-          <a:p>
-            <a:pPr algn="ctr"/>
-            <a:r>
-              <a:rPr sz="1100" b="1">
-                <a:solidFill>
-                  <a:srgbClr val="1A6B6B"/>
-                </a:solidFill>
-                <a:latin typeface="Calibri"/>
-              </a:rPr>
-              <a:t>ACADEMIC &amp; PROFESSIONAL ROLES</a:t>
-            </a:r>
-          </a:p>
-          <a:p>
-            <a:pPr>
-              <a:spcBef>
-                <a:spcPts val="600"/>
-              </a:spcBef>
-            </a:pPr>
-            <a:r>
-              <a:rPr sz="950" b="1">
-                <a:solidFill>
-                  <a:srgbClr val="0F2340"/>
-                </a:solidFill>
-                <a:latin typeface="Calibri"/>
-              </a:rPr>
-              <a:t>▪  Assistant Professor (Public Health)</a:t>
-            </a:r>
-          </a:p>
-          <a:p>
-            <a:r>
-              <a:rPr sz="850" b="1">
-                <a:solidFill>
-                  <a:srgbClr val="C47C3E"/>
-                </a:solidFill>
-                <a:latin typeface="Calibri"/>
-              </a:rPr>
-              <a:t>   Ramaiah School of Public Health, MSRUAS (2025–Present)</a:t>
-            </a:r>
-          </a:p>
-          <a:p>
-            <a:r>
-              <a:rPr sz="850">
-                <a:solidFill>
-                  <a:srgbClr val="555F73"/>
-                </a:solidFill>
-                <a:latin typeface="Calibri"/>
-              </a:rPr>
-              <a:t>   Teaching MPH programme: Research Methodology, Biostatistics, Technology in Public Health, and NCDs.</a:t>
-            </a:r>
-          </a:p>
-          <a:p>
-            <a:pPr>
-              <a:spcBef>
-                <a:spcPts val="600"/>
-              </a:spcBef>
-            </a:pPr>
-            <a:r>
-              <a:rPr sz="950" b="1">
-                <a:solidFill>
-                  <a:srgbClr val="0F2340"/>
-                </a:solidFill>
-                <a:latin typeface="Calibri"/>
-              </a:rPr>
-              <a:t>▪  Scientist-D / Senior Research Officer</a:t>
-            </a:r>
-          </a:p>
-          <a:p>
-            <a:r>
-              <a:rPr sz="850" b="1">
-                <a:solidFill>
-                  <a:srgbClr val="C47C3E"/>
-                </a:solidFill>
-                <a:latin typeface="Calibri"/>
-              </a:rPr>
-              <a:t>   PGIMER, Chandigarh (Nov 2024–Jul 2025)</a:t>
-            </a:r>
-          </a:p>
-          <a:p>
-            <a:r>
-              <a:rPr sz="850">
-                <a:solidFill>
-                  <a:srgbClr val="555F73"/>
-                </a:solidFill>
-                <a:latin typeface="Calibri"/>
-              </a:rPr>
-              <a:t>   Involved in developing online Health Technology Assessment (HTA) course.</a:t>
-            </a:r>
-          </a:p>
-          <a:p>
-            <a:pPr>
-              <a:spcBef>
-                <a:spcPts val="600"/>
-              </a:spcBef>
-            </a:pPr>
-            <a:r>
-              <a:rPr sz="950" b="1">
-                <a:solidFill>
-                  <a:srgbClr val="0F2340"/>
-                </a:solidFill>
-                <a:latin typeface="Calibri"/>
-              </a:rPr>
-              <a:t>▪  Field Investigator</a:t>
-            </a:r>
-          </a:p>
-          <a:p>
-            <a:r>
-              <a:rPr sz="850" b="1">
-                <a:solidFill>
-                  <a:srgbClr val="C47C3E"/>
-                </a:solidFill>
-                <a:latin typeface="Calibri"/>
-              </a:rPr>
-              <a:t>   World Health Organization (WHO) / JSS Medical College</a:t>
-            </a:r>
-          </a:p>
-          <a:p>
-            <a:r>
-              <a:rPr sz="850">
-                <a:solidFill>
-                  <a:srgbClr val="555F73"/>
-                </a:solidFill>
-                <a:latin typeface="Calibri"/>
-              </a:rPr>
-              <a:t>   Multi-centre clinical trial on oxygen &amp; respiratory support in COVID-19 in LMICs.</a:t>
-            </a:r>
-          </a:p>
-        </p:txBody>
-      </p:sp>
-      <p:sp>
-        <p:nvSpPr>
-          <p:cNvPr id="14" name="Rounded Rectangle 13"/>
-          <p:cNvSpPr/>
-          <p:nvPr/>
-        </p:nvSpPr>
-        <p:spPr>
-          <a:xfrm>
-            <a:off x="4114800" y="4919472"/>
-            <a:ext cx="7699248" cy="1389888"/>
-          </a:xfrm>
-          <a:prstGeom prst="roundRect">
-            <a:avLst/>
-          </a:prstGeom>
-          <a:solidFill>
-            <a:srgbClr val="FFFFFF"/>
-          </a:solidFill>
-          <a:ln w="15240">
-            <a:solidFill>
-              <a:srgbClr val="D7E1EE"/>
-            </a:solidFill>
-          </a:ln>
-        </p:spPr>
-        <p:style>
-          <a:lnRef idx="1">
-            <a:schemeClr val="accent1"/>
-          </a:lnRef>
-          <a:fillRef idx="3">
-            <a:schemeClr val="accent1"/>
-          </a:fillRef>
-          <a:effectRef idx="2">
-            <a:schemeClr val="accent1"/>
-          </a:effectRef>
-          <a:fontRef idx="minor">
-            <a:schemeClr val="lt1"/>
-          </a:fontRef>
-        </p:style>
-        <p:txBody>
-          <a:bodyPr rtlCol="0" anchor="ctr" wrap="square" tIns="128016" lIns="201168" rIns="201168" bIns="109728"/>
-          <a:lstStyle/>
-          <a:p>
-            <a:pPr algn="ctr"/>
-            <a:r>
-              <a:rPr sz="1050" b="1">
-                <a:solidFill>
-                  <a:srgbClr val="1A6B6B"/>
-                </a:solidFill>
-                <a:latin typeface="Calibri"/>
-              </a:rPr>
-              <a:t>EDITORIAL APPOINTMENTS &amp; INTERNATIONAL AFFILIATIONS</a:t>
-            </a:r>
-          </a:p>
-          <a:p>
-            <a:pPr>
-              <a:spcBef>
-                <a:spcPts val="400"/>
-              </a:spcBef>
-            </a:pPr>
-            <a:r>
-              <a:rPr sz="919" b="1">
-                <a:solidFill>
-                  <a:srgbClr val="0F2340"/>
-                </a:solidFill>
-                <a:latin typeface="Calibri"/>
-              </a:rPr>
-              <a:t>• Associate Editor: </a:t>
-            </a:r>
-            <a:r>
-              <a:rPr sz="919">
-                <a:solidFill>
-                  <a:srgbClr val="555F73"/>
-                </a:solidFill>
-                <a:latin typeface="Calibri"/>
-              </a:rPr>
-              <a:t>Archives of Public Health (BMC / Springer Nature)   |   Clinical Epidemiology and Global Health (Elsevier)</a:t>
-            </a:r>
-          </a:p>
-          <a:p>
-            <a:pPr>
-              <a:spcBef>
-                <a:spcPts val="300"/>
-              </a:spcBef>
-            </a:pPr>
-            <a:r>
-              <a:rPr sz="919" b="1">
-                <a:solidFill>
-                  <a:srgbClr val="0F2340"/>
-                </a:solidFill>
-                <a:latin typeface="Calibri"/>
-              </a:rPr>
-              <a:t>• Professional Memberships: </a:t>
-            </a:r>
-            <a:r>
-              <a:rPr sz="919">
-                <a:solidFill>
-                  <a:srgbClr val="555F73"/>
                 </a:solidFill>
                 <a:latin typeface="Calibri"/>
               </a:rPr>

</xml_diff>